<commit_message>
feat: expand presentation with bilingual technical sources and roadmap slides
Agent-Logs-Url: https://github.com/the3miaphysite3engineer3/copticapp/sessions/dce82b8a-932b-44a1-8c0c-b782b0f5f9da

Co-authored-by: the3miaphysite3engineer3 <71743801+the3miaphysite3engineer3@users.noreply.github.com>
</commit_message>
<xml_diff>
--- a/CopticCompass_Presentation.pptx
+++ b/CopticCompass_Presentation.pptx
@@ -18,6 +18,8 @@
     <p:sldId id="263" r:id="rId12"/>
     <p:sldId id="264" r:id="rId13"/>
     <p:sldId id="265" r:id="rId14"/>
+    <p:sldId id="266" r:id="rId15"/>
+    <p:sldId id="267" r:id="rId16"/>
   </p:sldIdLst>
   <p:sldSz cy="5143500" cx="9144000"/>
   <p:notesSz cx="5143500" cy="9144000"/>
@@ -4918,6 +4920,286 @@
 </p:sld>
 </file>
 
+<file path=ppt/slides/slide11.xml><?xml version="1.0" encoding="utf-8"?>
+<p:sld xmlns:a="http://schemas.openxmlformats.org/drawingml/2006/main" xmlns:p="http://schemas.openxmlformats.org/presentationml/2006/main" xmlns:r="http://schemas.openxmlformats.org/officeDocument/2006/relationships">
+  <p:cSld>
+    <p:spTree>
+      <p:nvGrpSpPr>
+        <p:cNvPr id="1" name=""/>
+        <p:cNvGrpSpPr/>
+        <p:nvPr/>
+      </p:nvGrpSpPr>
+      <p:grpSpPr/>
+      <p:sp>
+        <p:nvSpPr>
+          <p:cNvPr id="2" name="TextBox 1"/>
+          <p:cNvSpPr txBox="1"/>
+          <p:nvPr/>
+        </p:nvSpPr>
+        <p:spPr>
+          <a:xfrm>
+            <a:off x="457200" y="320040"/>
+            <a:ext cx="11247120" cy="731520"/>
+          </a:xfrm>
+          <a:prstGeom prst="rect">
+            <a:avLst/>
+          </a:prstGeom>
+          <a:noFill/>
+        </p:spPr>
+        <p:txBody>
+          <a:bodyPr wrap="none">
+            <a:spAutoFit/>
+          </a:bodyPr>
+          <a:lstStyle/>
+          <a:p>
+            <a:pPr>
+              <a:defRPr sz="3000" b="1"/>
+            </a:pPr>
+            <a:r>
+              <a:t>Technical Foundations &amp; Sources | الأسس التقنية والمصادر</a:t>
+            </a:r>
+          </a:p>
+        </p:txBody>
+      </p:sp>
+      <p:sp>
+        <p:nvSpPr>
+          <p:cNvPr id="3" name="TextBox 2"/>
+          <p:cNvSpPr txBox="1"/>
+          <p:nvPr/>
+        </p:nvSpPr>
+        <p:spPr>
+          <a:xfrm>
+            <a:off x="548640" y="1188720"/>
+            <a:ext cx="10972800" cy="5120640"/>
+          </a:xfrm>
+          <a:prstGeom prst="rect">
+            <a:avLst/>
+          </a:prstGeom>
+          <a:noFill/>
+        </p:spPr>
+        <p:txBody>
+          <a:bodyPr wrap="none">
+            <a:spAutoFit/>
+          </a:bodyPr>
+          <a:lstStyle/>
+          <a:p>
+            <a:pPr>
+              <a:defRPr sz="1600"/>
+            </a:pPr>
+            <a:r>
+              <a:t>EN: Coptic Compass combines a structured dictionary, grammar engine, and Shenute AI (RAG + vector search) for grounded educational answers.</a:t>
+            </a:r>
+          </a:p>
+          <a:p>
+            <a:pPr>
+              <a:defRPr sz="1600"/>
+            </a:pPr>
+            <a:r>
+              <a:t>AR: يجمع كوبتيك كومباس بين قاموس منظم ومحرك نحو وشنودة للذكاء الاصطناعي (RAG + بحث متجهي) لتقديم إجابات تعليمية موثوقة.</a:t>
+            </a:r>
+          </a:p>
+          <a:p>
+            <a:pPr>
+              <a:defRPr sz="1600"/>
+            </a:pPr>
+            <a:r>
+              <a:t>EN: Core evidence sources include verified lexicons, curated grammar references, publications, and manuscript-oriented study materials.</a:t>
+            </a:r>
+          </a:p>
+          <a:p>
+            <a:pPr>
+              <a:defRPr sz="1600"/>
+            </a:pPr>
+            <a:r>
+              <a:t>AR: تشمل مصادر المعرفة الأساسية معاجم موثقة ومراجع نحوية منقحة ومنشورات أكاديمية ومواد دراسية مرتبطة بالمخطوطات.</a:t>
+            </a:r>
+          </a:p>
+          <a:p>
+            <a:pPr>
+              <a:defRPr sz="1600"/>
+            </a:pPr>
+            <a:r>
+              <a:t>EN: AI responses are designed to reference authoritative Coptic scholarship and align with Church and academic study standards.</a:t>
+            </a:r>
+          </a:p>
+          <a:p>
+            <a:pPr>
+              <a:defRPr sz="1600"/>
+            </a:pPr>
+            <a:r>
+              <a:t>AR: صُممت إجابات الذكاء الاصطناعي للاستناد إلى مصادر قبطية معتمدة وبما يتوافق مع المعايير الكنسية والأكاديمية.</a:t>
+            </a:r>
+          </a:p>
+          <a:p>
+            <a:pPr>
+              <a:defRPr sz="1600"/>
+            </a:pPr>
+            <a:r>
+              <a:t>EN: Repository and transparency: https://github.com/KyroHub/CopticCompass</a:t>
+            </a:r>
+          </a:p>
+          <a:p>
+            <a:pPr>
+              <a:defRPr sz="1600"/>
+            </a:pPr>
+            <a:r>
+              <a:t>AR: المستودع والشفافية: https://github.com/KyroHub/CopticCompass</a:t>
+            </a:r>
+          </a:p>
+        </p:txBody>
+      </p:sp>
+    </p:spTree>
+  </p:cSld>
+  <p:clrMapOvr>
+    <a:masterClrMapping/>
+  </p:clrMapOvr>
+</p:sld>
+</file>
+
+<file path=ppt/slides/slide12.xml><?xml version="1.0" encoding="utf-8"?>
+<p:sld xmlns:a="http://schemas.openxmlformats.org/drawingml/2006/main" xmlns:p="http://schemas.openxmlformats.org/presentationml/2006/main" xmlns:r="http://schemas.openxmlformats.org/officeDocument/2006/relationships">
+  <p:cSld>
+    <p:spTree>
+      <p:nvGrpSpPr>
+        <p:cNvPr id="1" name=""/>
+        <p:cNvGrpSpPr/>
+        <p:nvPr/>
+      </p:nvGrpSpPr>
+      <p:grpSpPr/>
+      <p:sp>
+        <p:nvSpPr>
+          <p:cNvPr id="2" name="TextBox 1"/>
+          <p:cNvSpPr txBox="1"/>
+          <p:nvPr/>
+        </p:nvSpPr>
+        <p:spPr>
+          <a:xfrm>
+            <a:off x="457200" y="320040"/>
+            <a:ext cx="11247120" cy="731520"/>
+          </a:xfrm>
+          <a:prstGeom prst="rect">
+            <a:avLst/>
+          </a:prstGeom>
+          <a:noFill/>
+        </p:spPr>
+        <p:txBody>
+          <a:bodyPr wrap="none">
+            <a:spAutoFit/>
+          </a:bodyPr>
+          <a:lstStyle/>
+          <a:p>
+            <a:pPr>
+              <a:defRPr sz="3000" b="1"/>
+            </a:pPr>
+            <a:r>
+              <a:t>Future Prospects &amp; Open Source | الآفاق المستقبلية والمصدر المفتوح</a:t>
+            </a:r>
+          </a:p>
+        </p:txBody>
+      </p:sp>
+      <p:sp>
+        <p:nvSpPr>
+          <p:cNvPr id="3" name="TextBox 2"/>
+          <p:cNvSpPr txBox="1"/>
+          <p:nvPr/>
+        </p:nvSpPr>
+        <p:spPr>
+          <a:xfrm>
+            <a:off x="548640" y="1188720"/>
+            <a:ext cx="10972800" cy="5120640"/>
+          </a:xfrm>
+          <a:prstGeom prst="rect">
+            <a:avLst/>
+          </a:prstGeom>
+          <a:noFill/>
+        </p:spPr>
+        <p:txBody>
+          <a:bodyPr wrap="none">
+            <a:spAutoFit/>
+          </a:bodyPr>
+          <a:lstStyle/>
+          <a:p>
+            <a:pPr>
+              <a:defRPr sz="1600"/>
+            </a:pPr>
+            <a:r>
+              <a:t>EN: Planned roadmap includes Coptic speech-to-text for liturgical and educational pronunciation workflows.</a:t>
+            </a:r>
+          </a:p>
+          <a:p>
+            <a:pPr>
+              <a:defRPr sz="1600"/>
+            </a:pPr>
+            <a:r>
+              <a:t>AR: تتضمن الخطة القادمة إضافة تحويل الكلام إلى نص قبطي لدعم التدريب النطقي التعليمي والليتورجي.</a:t>
+            </a:r>
+          </a:p>
+          <a:p>
+            <a:pPr>
+              <a:defRPr sz="1600"/>
+            </a:pPr>
+            <a:r>
+              <a:t>EN: Hymns AI Tutor: interactive coaching for hymn pronunciation, meaning, and structured practice.</a:t>
+            </a:r>
+          </a:p>
+          <a:p>
+            <a:pPr>
+              <a:defRPr sz="1600"/>
+            </a:pPr>
+            <a:r>
+              <a:t>AR: مُعلّم الألحان بالذكاء الاصطناعي: تدريب تفاعلي للنطق والمعنى وخطط ممارسة منظمة.</a:t>
+            </a:r>
+          </a:p>
+          <a:p>
+            <a:pPr>
+              <a:defRPr sz="1600"/>
+            </a:pPr>
+            <a:r>
+              <a:t>EN: Offline local AI mode is planned for privacy-focused use in churches, classrooms, and low-connectivity regions.</a:t>
+            </a:r>
+          </a:p>
+          <a:p>
+            <a:pPr>
+              <a:defRPr sz="1600"/>
+            </a:pPr>
+            <a:r>
+              <a:t>AR: يجري التخطيط لوضع ذكاء اصطناعي محلي دون اتصال بالإنترنت لخصوصية أعلى في الكنائس والفصول والمناطق ضعيفة الاتصال.</a:t>
+            </a:r>
+          </a:p>
+          <a:p>
+            <a:pPr>
+              <a:defRPr sz="1600"/>
+            </a:pPr>
+            <a:r>
+              <a:t>EN: Coptic Compass is open source — anyone can contribute code or Coptic educational content.</a:t>
+            </a:r>
+          </a:p>
+          <a:p>
+            <a:pPr>
+              <a:defRPr sz="1600"/>
+            </a:pPr>
+            <a:r>
+              <a:t>AR: كوبتيك كومباس مشروع مفتوح المصدر — ويمكن لأي شخص المساهمة بالكود أو بالمحتوى التعليمي القبطي.</a:t>
+            </a:r>
+          </a:p>
+          <a:p>
+            <a:pPr>
+              <a:defRPr sz="1600"/>
+            </a:pPr>
+            <a:r>
+              <a:t>EN/AR: Contribute via GitHub issues and pull requests | ساهم عبر GitHub من خلال البلاغات وطلبات الدمج.</a:t>
+            </a:r>
+          </a:p>
+        </p:txBody>
+      </p:sp>
+    </p:spTree>
+  </p:cSld>
+  <p:clrMapOvr>
+    <a:masterClrMapping/>
+  </p:clrMapOvr>
+</p:sld>
+</file>
+
 <file path=ppt/slides/slide2.xml><?xml version="1.0" encoding="utf-8"?>
 <p:sld xmlns:a="http://schemas.openxmlformats.org/drawingml/2006/main" xmlns:r="http://schemas.openxmlformats.org/officeDocument/2006/relationships" xmlns:mc="http://schemas.openxmlformats.org/markup-compatibility/2006" xmlns:mv="urn:schemas-microsoft-com:mac:vml" xmlns:p="http://schemas.openxmlformats.org/presentationml/2006/main" xmlns:c="http://schemas.openxmlformats.org/drawingml/2006/chart" xmlns:dgm="http://schemas.openxmlformats.org/drawingml/2006/diagram" xmlns:o="urn:schemas-microsoft-com:office:office" xmlns:v="urn:schemas-microsoft-com:vml" xmlns:pvml="urn:schemas-microsoft-com:office:powerpoint" xmlns:com="http://schemas.openxmlformats.org/drawingml/2006/compatibility" xmlns:p14="http://schemas.microsoft.com/office/powerpoint/2010/main" xmlns:p15="http://schemas.microsoft.com/office/powerpoint/2012/main" xmlns:ahyp="http://schemas.microsoft.com/office/drawing/2018/hyperlinkcolor">
   <p:cSld>

</xml_diff>